<commit_message>
Regenerate PowerPoint downloads: strip ( ) from lyrics text
</commit_message>
<xml_diff>
--- a/assets/pptx/catalog-104.pptx
+++ b/assets/pptx/catalog-104.pptx
@@ -3300,7 +3300,7 @@
                 <a:ea typeface="Ebrima"/>
                 <a:cs typeface="Ebrima"/>
               </a:rPr>
-              <a:t>ቅዱስ ቅዱስ ቅዱስ ነህና (2X)</a:t>
+              <a:t>ቅዱስ ቅዱስ ቅዱስ ነህና 2X</a:t>
             </a:r>
           </a:p>
         </p:txBody>
@@ -3421,7 +3421,7 @@
                 <a:ea typeface="Ebrima"/>
                 <a:cs typeface="Ebrima"/>
               </a:rPr>
-              <a:t>ክቡር ነህ እግዚአብሔር ተመስገን ብለንሀል (2X)</a:t>
+              <a:t>ክቡር ነህ እግዚአብሔር ተመስገን ብለንሀል 2X</a:t>
             </a:r>
           </a:p>
         </p:txBody>
@@ -3542,7 +3542,7 @@
                 <a:ea typeface="Ebrima"/>
                 <a:cs typeface="Ebrima"/>
               </a:rPr>
-              <a:t>ቅዱስ ቅዱስ ቅዱስ ነህና (2X)</a:t>
+              <a:t>ቅዱስ ቅዱስ ቅዱስ ነህና 2X</a:t>
             </a:r>
           </a:p>
         </p:txBody>
@@ -3905,7 +3905,7 @@
                 <a:ea typeface="Ebrima"/>
                 <a:cs typeface="Ebrima"/>
               </a:rPr>
-              <a:t>ቅዱስ ቅዱስ ቅዱስ ነህና (2X)</a:t>
+              <a:t>ቅዱስ ቅዱስ ቅዱስ ነህና 2X</a:t>
             </a:r>
           </a:p>
         </p:txBody>

</xml_diff>